<commit_message>
Epiroc Q3 2026: add CEO quote from the full transcript
Co-Authored-By: Claude Opus 5.5 <noreply@anthropic.com>
Claude-Session: https://claude.ai/code/session_014JFw9wsnkgedq53FQx57gS
</commit_message>
<xml_diff>
--- a/reports/EPIA_Q3_2026/Earnings_Update_EPIA_Q32026.pptx
+++ b/reports/EPIA_Q3_2026/Earnings_Update_EPIA_Q32026.pptx
@@ -1301,14 +1301,120 @@
       </p:sp>
       <p:sp>
         <p:nvSpPr>
-          <p:cNvPr id="9" name="Text 5"/>
-          <p:cNvSpPr txBox="1"/>
+          <p:cNvPr id="9" name="Shape 5"/>
+          <p:cNvSpPr/>
           <p:nvPr/>
         </p:nvSpPr>
         <p:spPr>
           <a:xfrm>
             <a:off x="539496" y="1602994"/>
-            <a:ext cx="6483096" cy="488975"/>
+            <a:ext cx="42977" cy="536067"/>
+          </a:xfrm>
+          <a:prstGeom prst="rect">
+            <a:avLst/>
+          </a:prstGeom>
+          <a:solidFill>
+            <a:srgbClr val="FF6C0E"/>
+          </a:solidFill>
+          <a:ln w="12700">
+            <a:solidFill>
+              <a:srgbClr val="FF6C0E"/>
+            </a:solidFill>
+            <a:prstDash val="solid"/>
+          </a:ln>
+        </p:spPr>
+      </p:sp>
+      <p:sp>
+        <p:nvSpPr>
+          <p:cNvPr id="10" name="Text 6"/>
+          <p:cNvSpPr txBox="1"/>
+          <p:nvPr/>
+        </p:nvSpPr>
+        <p:spPr>
+          <a:xfrm>
+            <a:off x="722376" y="1621282"/>
+            <a:ext cx="6300216" cy="298323"/>
+          </a:xfrm>
+          <a:prstGeom prst="rect">
+            <a:avLst/>
+          </a:prstGeom>
+          <a:noFill/>
+          <a:ln/>
+        </p:spPr>
+        <p:txBody>
+          <a:bodyPr wrap="square" lIns="0" tIns="0" rIns="0" bIns="0" rtlCol="0" anchor="t"/>
+          <a:lstStyle/>
+          <a:p>
+            <a:pPr indent="0" marL="0">
+              <a:lnSpc>
+                <a:spcPct val="112500"/>
+              </a:lnSpc>
+              <a:buNone/>
+            </a:pPr>
+            <a:r>
+              <a:rPr lang="en-US" sz="870" b="1" dirty="0">
+                <a:solidFill>
+                  <a:srgbClr val="202945"/>
+                </a:solidFill>
+                <a:latin typeface="Nunito" pitchFamily="34" charset="0"/>
+                <a:ea typeface="Nunito" pitchFamily="34" charset="-122"/>
+                <a:cs typeface="Nunito" pitchFamily="34" charset="-120"/>
+              </a:rPr>
+              <a:t>“The strong order development needs to translate into revenues and cash. And we are focused on improving that conversion while continuing to serve our customers well.”</a:t>
+            </a:r>
+            <a:endParaRPr lang="en-US" sz="870" dirty="0"/>
+          </a:p>
+        </p:txBody>
+      </p:sp>
+      <p:sp>
+        <p:nvSpPr>
+          <p:cNvPr id="11" name="Text 7"/>
+          <p:cNvSpPr txBox="1"/>
+          <p:nvPr/>
+        </p:nvSpPr>
+        <p:spPr>
+          <a:xfrm>
+            <a:off x="722376" y="1956181"/>
+            <a:ext cx="6300216" cy="155448"/>
+          </a:xfrm>
+          <a:prstGeom prst="rect">
+            <a:avLst/>
+          </a:prstGeom>
+          <a:noFill/>
+          <a:ln/>
+        </p:spPr>
+        <p:txBody>
+          <a:bodyPr wrap="square" lIns="0" tIns="0" rIns="0" bIns="0" rtlCol="0" anchor="t"/>
+          <a:lstStyle/>
+          <a:p>
+            <a:pPr indent="0" marL="0">
+              <a:buNone/>
+            </a:pPr>
+            <a:r>
+              <a:rPr lang="en-US" sz="700" b="1" dirty="0">
+                <a:solidFill>
+                  <a:srgbClr val="6B7280"/>
+                </a:solidFill>
+                <a:latin typeface="Nunito" pitchFamily="34" charset="0"/>
+                <a:ea typeface="Nunito" pitchFamily="34" charset="-122"/>
+                <a:cs typeface="Nunito" pitchFamily="34" charset="-120"/>
+              </a:rPr>
+              <a:t>Helena Hedblom, President and Chief Executive Officer, Q3 2026 results call, 28 October 2026</a:t>
+            </a:r>
+            <a:endParaRPr lang="en-US" sz="700" dirty="0"/>
+          </a:p>
+        </p:txBody>
+      </p:sp>
+      <p:sp>
+        <p:nvSpPr>
+          <p:cNvPr id="12" name="Text 8"/>
+          <p:cNvSpPr txBox="1"/>
+          <p:nvPr/>
+        </p:nvSpPr>
+        <p:spPr>
+          <a:xfrm>
+            <a:off x="539496" y="2257933"/>
+            <a:ext cx="6483096" cy="332080"/>
           </a:xfrm>
           <a:prstGeom prst="rect">
             <a:avLst/>
@@ -1335,7 +1441,7 @@
                 <a:ea typeface="Nunito" pitchFamily="34" charset="-122"/>
                 <a:cs typeface="Nunito" pitchFamily="34" charset="-120"/>
               </a:rPr>
-              <a:t>Epiroc makes drilling rigs, underground loaders, rock tools and attachments for mining and infrastructure customers, and services the installed fleet. Mining accounts for 83% of orders; quarterly revenue is SEK 16.8bn. Listed in Stockholm.</a:t>
+              <a:t>Epiroc makes drilling rigs, underground loaders, rock tools and attachments for mining and infrastructure customers, and services the installed fleet. Mining accounts for 83% of orders; quarterly revenue is SEK 16.8bn. Stockholm-listed.</a:t>
             </a:r>
             <a:endParaRPr lang="en-US" sz="870" dirty="0"/>
           </a:p>
@@ -1343,13 +1449,13 @@
       </p:sp>
       <p:sp>
         <p:nvSpPr>
-          <p:cNvPr id="10" name="Text 6"/>
-          <p:cNvSpPr txBox="1"/>
-          <p:nvPr/>
-        </p:nvSpPr>
-        <p:spPr>
-          <a:xfrm>
-            <a:off x="539496" y="2210841"/>
+          <p:cNvPr id="13" name="Text 9"/>
+          <p:cNvSpPr txBox="1"/>
+          <p:nvPr/>
+        </p:nvSpPr>
+        <p:spPr>
+          <a:xfrm>
+            <a:off x="539496" y="2708885"/>
             <a:ext cx="6483096" cy="219456"/>
           </a:xfrm>
           <a:prstGeom prst="rect">
@@ -1382,13 +1488,13 @@
       </p:sp>
       <p:sp>
         <p:nvSpPr>
-          <p:cNvPr id="11" name="Text 7"/>
-          <p:cNvSpPr txBox="1"/>
-          <p:nvPr/>
-        </p:nvSpPr>
-        <p:spPr>
-          <a:xfrm>
-            <a:off x="539496" y="2471445"/>
+          <p:cNvPr id="14" name="Text 10"/>
+          <p:cNvSpPr txBox="1"/>
+          <p:nvPr/>
+        </p:nvSpPr>
+        <p:spPr>
+          <a:xfrm>
+            <a:off x="539496" y="2969489"/>
             <a:ext cx="576072" cy="156896"/>
           </a:xfrm>
           <a:prstGeom prst="rect">
@@ -1421,13 +1527,13 @@
       </p:sp>
       <p:sp>
         <p:nvSpPr>
-          <p:cNvPr id="12" name="Text 8"/>
-          <p:cNvSpPr txBox="1"/>
-          <p:nvPr/>
-        </p:nvSpPr>
-        <p:spPr>
-          <a:xfrm>
-            <a:off x="1133856" y="2448585"/>
+          <p:cNvPr id="15" name="Text 11"/>
+          <p:cNvSpPr txBox="1"/>
+          <p:nvPr/>
+        </p:nvSpPr>
+        <p:spPr>
+          <a:xfrm>
+            <a:off x="1133856" y="2946629"/>
             <a:ext cx="5888736" cy="156896"/>
           </a:xfrm>
           <a:prstGeom prst="rect">
@@ -1463,13 +1569,13 @@
       </p:sp>
       <p:sp>
         <p:nvSpPr>
-          <p:cNvPr id="13" name="Text 9"/>
-          <p:cNvSpPr txBox="1"/>
-          <p:nvPr/>
-        </p:nvSpPr>
-        <p:spPr>
-          <a:xfrm>
-            <a:off x="539496" y="2674061"/>
+          <p:cNvPr id="16" name="Text 12"/>
+          <p:cNvSpPr txBox="1"/>
+          <p:nvPr/>
+        </p:nvSpPr>
+        <p:spPr>
+          <a:xfrm>
+            <a:off x="539496" y="3172104"/>
             <a:ext cx="576072" cy="156896"/>
           </a:xfrm>
           <a:prstGeom prst="rect">
@@ -1502,13 +1608,13 @@
       </p:sp>
       <p:sp>
         <p:nvSpPr>
-          <p:cNvPr id="14" name="Text 10"/>
-          <p:cNvSpPr txBox="1"/>
-          <p:nvPr/>
-        </p:nvSpPr>
-        <p:spPr>
-          <a:xfrm>
-            <a:off x="1133856" y="2651201"/>
+          <p:cNvPr id="17" name="Text 13"/>
+          <p:cNvSpPr txBox="1"/>
+          <p:nvPr/>
+        </p:nvSpPr>
+        <p:spPr>
+          <a:xfrm>
+            <a:off x="1133856" y="3149244"/>
             <a:ext cx="5888736" cy="156896"/>
           </a:xfrm>
           <a:prstGeom prst="rect">
@@ -1544,13 +1650,13 @@
       </p:sp>
       <p:sp>
         <p:nvSpPr>
-          <p:cNvPr id="15" name="Text 11"/>
-          <p:cNvSpPr txBox="1"/>
-          <p:nvPr/>
-        </p:nvSpPr>
-        <p:spPr>
-          <a:xfrm>
-            <a:off x="539496" y="2876677"/>
+          <p:cNvPr id="18" name="Text 14"/>
+          <p:cNvSpPr txBox="1"/>
+          <p:nvPr/>
+        </p:nvSpPr>
+        <p:spPr>
+          <a:xfrm>
+            <a:off x="539496" y="3374720"/>
             <a:ext cx="576072" cy="156896"/>
           </a:xfrm>
           <a:prstGeom prst="rect">
@@ -1583,13 +1689,13 @@
       </p:sp>
       <p:sp>
         <p:nvSpPr>
-          <p:cNvPr id="16" name="Text 12"/>
-          <p:cNvSpPr txBox="1"/>
-          <p:nvPr/>
-        </p:nvSpPr>
-        <p:spPr>
-          <a:xfrm>
-            <a:off x="1133856" y="2853817"/>
+          <p:cNvPr id="19" name="Text 15"/>
+          <p:cNvSpPr txBox="1"/>
+          <p:nvPr/>
+        </p:nvSpPr>
+        <p:spPr>
+          <a:xfrm>
+            <a:off x="1133856" y="3351860"/>
             <a:ext cx="5888736" cy="156896"/>
           </a:xfrm>
           <a:prstGeom prst="rect">
@@ -1625,13 +1731,13 @@
       </p:sp>
       <p:sp>
         <p:nvSpPr>
-          <p:cNvPr id="17" name="Text 13"/>
-          <p:cNvSpPr txBox="1"/>
-          <p:nvPr/>
-        </p:nvSpPr>
-        <p:spPr>
-          <a:xfrm>
-            <a:off x="539496" y="3079293"/>
+          <p:cNvPr id="20" name="Text 16"/>
+          <p:cNvSpPr txBox="1"/>
+          <p:nvPr/>
+        </p:nvSpPr>
+        <p:spPr>
+          <a:xfrm>
+            <a:off x="539496" y="3577336"/>
             <a:ext cx="576072" cy="156896"/>
           </a:xfrm>
           <a:prstGeom prst="rect">
@@ -1664,13 +1770,13 @@
       </p:sp>
       <p:sp>
         <p:nvSpPr>
-          <p:cNvPr id="18" name="Text 14"/>
-          <p:cNvSpPr txBox="1"/>
-          <p:nvPr/>
-        </p:nvSpPr>
-        <p:spPr>
-          <a:xfrm>
-            <a:off x="1133856" y="3056433"/>
+          <p:cNvPr id="21" name="Text 17"/>
+          <p:cNvSpPr txBox="1"/>
+          <p:nvPr/>
+        </p:nvSpPr>
+        <p:spPr>
+          <a:xfrm>
+            <a:off x="1133856" y="3554476"/>
             <a:ext cx="5888736" cy="156896"/>
           </a:xfrm>
           <a:prstGeom prst="rect">
@@ -1698,7 +1804,7 @@
                 <a:ea typeface="Nunito" pitchFamily="34" charset="-122"/>
                 <a:cs typeface="Nunito" pitchFamily="34" charset="-120"/>
               </a:rPr>
-              <a:t>24.8x forward earnings, in line with the average since the 2018 listing and down from 33.3x in February.</a:t>
+              <a:t>24.8x forward earnings, in line with its average since the 2018 listing; 33.3x in February.</a:t>
             </a:r>
             <a:endParaRPr lang="en-US" sz="870" dirty="0"/>
           </a:p>
@@ -1706,13 +1812,13 @@
       </p:sp>
       <p:sp>
         <p:nvSpPr>
-          <p:cNvPr id="19" name="Shape 15"/>
+          <p:cNvPr id="22" name="Shape 18"/>
           <p:cNvSpPr/>
           <p:nvPr/>
         </p:nvSpPr>
         <p:spPr>
           <a:xfrm>
-            <a:off x="539496" y="3341345"/>
+            <a:off x="539496" y="3839388"/>
             <a:ext cx="6483096" cy="640080"/>
           </a:xfrm>
           <a:prstGeom prst="rect">
@@ -1731,13 +1837,13 @@
       </p:sp>
       <p:sp>
         <p:nvSpPr>
-          <p:cNvPr id="20" name="Text 16"/>
-          <p:cNvSpPr txBox="1"/>
-          <p:nvPr/>
-        </p:nvSpPr>
-        <p:spPr>
-          <a:xfrm>
-            <a:off x="649224" y="3414497"/>
+          <p:cNvPr id="23" name="Text 19"/>
+          <p:cNvSpPr txBox="1"/>
+          <p:nvPr/>
+        </p:nvSpPr>
+        <p:spPr>
+          <a:xfrm>
+            <a:off x="649224" y="3912540"/>
             <a:ext cx="1437894" cy="137160"/>
           </a:xfrm>
           <a:prstGeom prst="rect">
@@ -1770,13 +1876,13 @@
       </p:sp>
       <p:sp>
         <p:nvSpPr>
-          <p:cNvPr id="21" name="Text 17"/>
-          <p:cNvSpPr txBox="1"/>
-          <p:nvPr/>
-        </p:nvSpPr>
-        <p:spPr>
-          <a:xfrm>
-            <a:off x="649224" y="3551657"/>
+          <p:cNvPr id="24" name="Text 20"/>
+          <p:cNvSpPr txBox="1"/>
+          <p:nvPr/>
+        </p:nvSpPr>
+        <p:spPr>
+          <a:xfrm>
+            <a:off x="649224" y="4049700"/>
             <a:ext cx="1437894" cy="201168"/>
           </a:xfrm>
           <a:prstGeom prst="rect">
@@ -1809,13 +1915,13 @@
       </p:sp>
       <p:sp>
         <p:nvSpPr>
-          <p:cNvPr id="22" name="Text 18"/>
-          <p:cNvSpPr txBox="1"/>
-          <p:nvPr/>
-        </p:nvSpPr>
-        <p:spPr>
-          <a:xfrm>
-            <a:off x="649224" y="3761969"/>
+          <p:cNvPr id="25" name="Text 21"/>
+          <p:cNvSpPr txBox="1"/>
+          <p:nvPr/>
+        </p:nvSpPr>
+        <p:spPr>
+          <a:xfrm>
+            <a:off x="649224" y="4260012"/>
             <a:ext cx="1437894" cy="137160"/>
           </a:xfrm>
           <a:prstGeom prst="rect">
@@ -1848,13 +1954,13 @@
       </p:sp>
       <p:sp>
         <p:nvSpPr>
-          <p:cNvPr id="23" name="Shape 19"/>
+          <p:cNvPr id="26" name="Shape 22"/>
           <p:cNvSpPr/>
           <p:nvPr/>
         </p:nvSpPr>
         <p:spPr>
           <a:xfrm>
-            <a:off x="2160270" y="3341345"/>
+            <a:off x="2160270" y="3839388"/>
             <a:ext cx="0" cy="640080"/>
           </a:xfrm>
           <a:prstGeom prst="line">
@@ -1871,13 +1977,13 @@
       </p:sp>
       <p:sp>
         <p:nvSpPr>
-          <p:cNvPr id="24" name="Text 20"/>
-          <p:cNvSpPr txBox="1"/>
-          <p:nvPr/>
-        </p:nvSpPr>
-        <p:spPr>
-          <a:xfrm>
-            <a:off x="2269998" y="3414497"/>
+          <p:cNvPr id="27" name="Text 23"/>
+          <p:cNvSpPr txBox="1"/>
+          <p:nvPr/>
+        </p:nvSpPr>
+        <p:spPr>
+          <a:xfrm>
+            <a:off x="2269998" y="3912540"/>
             <a:ext cx="1437894" cy="137160"/>
           </a:xfrm>
           <a:prstGeom prst="rect">
@@ -1910,13 +2016,13 @@
       </p:sp>
       <p:sp>
         <p:nvSpPr>
-          <p:cNvPr id="25" name="Text 21"/>
-          <p:cNvSpPr txBox="1"/>
-          <p:nvPr/>
-        </p:nvSpPr>
-        <p:spPr>
-          <a:xfrm>
-            <a:off x="2269998" y="3551657"/>
+          <p:cNvPr id="28" name="Text 24"/>
+          <p:cNvSpPr txBox="1"/>
+          <p:nvPr/>
+        </p:nvSpPr>
+        <p:spPr>
+          <a:xfrm>
+            <a:off x="2269998" y="4049700"/>
             <a:ext cx="1437894" cy="201168"/>
           </a:xfrm>
           <a:prstGeom prst="rect">
@@ -1949,13 +2055,13 @@
       </p:sp>
       <p:sp>
         <p:nvSpPr>
-          <p:cNvPr id="26" name="Text 22"/>
-          <p:cNvSpPr txBox="1"/>
-          <p:nvPr/>
-        </p:nvSpPr>
-        <p:spPr>
-          <a:xfrm>
-            <a:off x="2269998" y="3761969"/>
+          <p:cNvPr id="29" name="Text 25"/>
+          <p:cNvSpPr txBox="1"/>
+          <p:nvPr/>
+        </p:nvSpPr>
+        <p:spPr>
+          <a:xfrm>
+            <a:off x="2269998" y="4260012"/>
             <a:ext cx="1437894" cy="137160"/>
           </a:xfrm>
           <a:prstGeom prst="rect">
@@ -1988,13 +2094,13 @@
       </p:sp>
       <p:sp>
         <p:nvSpPr>
-          <p:cNvPr id="27" name="Shape 23"/>
+          <p:cNvPr id="30" name="Shape 26"/>
           <p:cNvSpPr/>
           <p:nvPr/>
         </p:nvSpPr>
         <p:spPr>
           <a:xfrm>
-            <a:off x="3781044" y="3341345"/>
+            <a:off x="3781044" y="3839388"/>
             <a:ext cx="0" cy="640080"/>
           </a:xfrm>
           <a:prstGeom prst="line">
@@ -2011,13 +2117,13 @@
       </p:sp>
       <p:sp>
         <p:nvSpPr>
-          <p:cNvPr id="28" name="Text 24"/>
-          <p:cNvSpPr txBox="1"/>
-          <p:nvPr/>
-        </p:nvSpPr>
-        <p:spPr>
-          <a:xfrm>
-            <a:off x="3890772" y="3414497"/>
+          <p:cNvPr id="31" name="Text 27"/>
+          <p:cNvSpPr txBox="1"/>
+          <p:nvPr/>
+        </p:nvSpPr>
+        <p:spPr>
+          <a:xfrm>
+            <a:off x="3890772" y="3912540"/>
             <a:ext cx="1437894" cy="137160"/>
           </a:xfrm>
           <a:prstGeom prst="rect">
@@ -2050,13 +2156,13 @@
       </p:sp>
       <p:sp>
         <p:nvSpPr>
-          <p:cNvPr id="29" name="Text 25"/>
-          <p:cNvSpPr txBox="1"/>
-          <p:nvPr/>
-        </p:nvSpPr>
-        <p:spPr>
-          <a:xfrm>
-            <a:off x="3890772" y="3551657"/>
+          <p:cNvPr id="32" name="Text 28"/>
+          <p:cNvSpPr txBox="1"/>
+          <p:nvPr/>
+        </p:nvSpPr>
+        <p:spPr>
+          <a:xfrm>
+            <a:off x="3890772" y="4049700"/>
             <a:ext cx="1437894" cy="201168"/>
           </a:xfrm>
           <a:prstGeom prst="rect">
@@ -2089,13 +2195,13 @@
       </p:sp>
       <p:sp>
         <p:nvSpPr>
-          <p:cNvPr id="30" name="Text 26"/>
-          <p:cNvSpPr txBox="1"/>
-          <p:nvPr/>
-        </p:nvSpPr>
-        <p:spPr>
-          <a:xfrm>
-            <a:off x="3890772" y="3761969"/>
+          <p:cNvPr id="33" name="Text 29"/>
+          <p:cNvSpPr txBox="1"/>
+          <p:nvPr/>
+        </p:nvSpPr>
+        <p:spPr>
+          <a:xfrm>
+            <a:off x="3890772" y="4260012"/>
             <a:ext cx="1437894" cy="137160"/>
           </a:xfrm>
           <a:prstGeom prst="rect">
@@ -2128,13 +2234,13 @@
       </p:sp>
       <p:sp>
         <p:nvSpPr>
-          <p:cNvPr id="31" name="Shape 27"/>
+          <p:cNvPr id="34" name="Shape 30"/>
           <p:cNvSpPr/>
           <p:nvPr/>
         </p:nvSpPr>
         <p:spPr>
           <a:xfrm>
-            <a:off x="5401818" y="3341345"/>
+            <a:off x="5401818" y="3839388"/>
             <a:ext cx="0" cy="640080"/>
           </a:xfrm>
           <a:prstGeom prst="line">
@@ -2151,13 +2257,13 @@
       </p:sp>
       <p:sp>
         <p:nvSpPr>
-          <p:cNvPr id="32" name="Text 28"/>
-          <p:cNvSpPr txBox="1"/>
-          <p:nvPr/>
-        </p:nvSpPr>
-        <p:spPr>
-          <a:xfrm>
-            <a:off x="5511546" y="3414497"/>
+          <p:cNvPr id="35" name="Text 31"/>
+          <p:cNvSpPr txBox="1"/>
+          <p:nvPr/>
+        </p:nvSpPr>
+        <p:spPr>
+          <a:xfrm>
+            <a:off x="5511546" y="3912540"/>
             <a:ext cx="1437894" cy="137160"/>
           </a:xfrm>
           <a:prstGeom prst="rect">
@@ -2190,13 +2296,13 @@
       </p:sp>
       <p:sp>
         <p:nvSpPr>
-          <p:cNvPr id="33" name="Text 29"/>
-          <p:cNvSpPr txBox="1"/>
-          <p:nvPr/>
-        </p:nvSpPr>
-        <p:spPr>
-          <a:xfrm>
-            <a:off x="5511546" y="3551657"/>
+          <p:cNvPr id="36" name="Text 32"/>
+          <p:cNvSpPr txBox="1"/>
+          <p:nvPr/>
+        </p:nvSpPr>
+        <p:spPr>
+          <a:xfrm>
+            <a:off x="5511546" y="4049700"/>
             <a:ext cx="1437894" cy="201168"/>
           </a:xfrm>
           <a:prstGeom prst="rect">
@@ -2229,13 +2335,13 @@
       </p:sp>
       <p:sp>
         <p:nvSpPr>
-          <p:cNvPr id="34" name="Text 30"/>
-          <p:cNvSpPr txBox="1"/>
-          <p:nvPr/>
-        </p:nvSpPr>
-        <p:spPr>
-          <a:xfrm>
-            <a:off x="5511546" y="3761969"/>
+          <p:cNvPr id="37" name="Text 33"/>
+          <p:cNvSpPr txBox="1"/>
+          <p:nvPr/>
+        </p:nvSpPr>
+        <p:spPr>
+          <a:xfrm>
+            <a:off x="5511546" y="4260012"/>
             <a:ext cx="1437894" cy="137160"/>
           </a:xfrm>
           <a:prstGeom prst="rect">
@@ -2268,13 +2374,13 @@
       </p:sp>
       <p:sp>
         <p:nvSpPr>
-          <p:cNvPr id="35" name="Text 31"/>
-          <p:cNvSpPr txBox="1"/>
-          <p:nvPr/>
-        </p:nvSpPr>
-        <p:spPr>
-          <a:xfrm>
-            <a:off x="539496" y="4100297"/>
+          <p:cNvPr id="38" name="Text 34"/>
+          <p:cNvSpPr txBox="1"/>
+          <p:nvPr/>
+        </p:nvSpPr>
+        <p:spPr>
+          <a:xfrm>
+            <a:off x="539496" y="4598340"/>
             <a:ext cx="6483096" cy="219456"/>
           </a:xfrm>
           <a:prstGeom prst="rect">
@@ -2307,13 +2413,13 @@
       </p:sp>
       <p:sp>
         <p:nvSpPr>
-          <p:cNvPr id="36" name="Text 32"/>
-          <p:cNvSpPr txBox="1"/>
-          <p:nvPr/>
-        </p:nvSpPr>
-        <p:spPr>
-          <a:xfrm>
-            <a:off x="539496" y="4347185"/>
+          <p:cNvPr id="39" name="Text 35"/>
+          <p:cNvSpPr txBox="1"/>
+          <p:nvPr/>
+        </p:nvSpPr>
+        <p:spPr>
+          <a:xfrm>
+            <a:off x="539496" y="4845228"/>
             <a:ext cx="6483096" cy="488975"/>
           </a:xfrm>
           <a:prstGeom prst="rect">
@@ -2349,13 +2455,13 @@
       </p:sp>
       <p:sp>
         <p:nvSpPr>
-          <p:cNvPr id="37" name="Text 33"/>
-          <p:cNvSpPr txBox="1"/>
-          <p:nvPr/>
-        </p:nvSpPr>
-        <p:spPr>
-          <a:xfrm>
-            <a:off x="539496" y="4915713"/>
+          <p:cNvPr id="40" name="Text 36"/>
+          <p:cNvSpPr txBox="1"/>
+          <p:nvPr/>
+        </p:nvSpPr>
+        <p:spPr>
+          <a:xfrm>
+            <a:off x="539496" y="5413756"/>
             <a:ext cx="6483096" cy="173736"/>
           </a:xfrm>
           <a:prstGeom prst="rect">
@@ -2402,13 +2508,13 @@
       </p:sp>
       <p:sp>
         <p:nvSpPr>
-          <p:cNvPr id="38" name="Text 34"/>
-          <p:cNvSpPr txBox="1"/>
-          <p:nvPr/>
-        </p:nvSpPr>
-        <p:spPr>
-          <a:xfrm>
-            <a:off x="539496" y="5089449"/>
+          <p:cNvPr id="41" name="Text 37"/>
+          <p:cNvSpPr txBox="1"/>
+          <p:nvPr/>
+        </p:nvSpPr>
+        <p:spPr>
+          <a:xfrm>
+            <a:off x="539496" y="5587492"/>
             <a:ext cx="6483096" cy="115570"/>
           </a:xfrm>
           <a:prstGeom prst="rect">
@@ -2444,7 +2550,7 @@
       </p:sp>
       <p:pic>
         <p:nvPicPr>
-          <p:cNvPr id="39" name="Image 2" descr="/home/claude/epi/c1_crop.png">    </p:cNvPr>
+          <p:cNvPr id="42" name="Image 2" descr="/home/claude/epi/c1_crop.png">    </p:cNvPr>
           <p:cNvPicPr>
             <a:picLocks noChangeAspect="1"/>
           </p:cNvPicPr>
@@ -2458,8 +2564,8 @@
         </p:blipFill>
         <p:spPr>
           <a:xfrm>
-            <a:off x="1511960" y="5250739"/>
-            <a:ext cx="4538167" cy="1415908"/>
+            <a:off x="1641622" y="5748782"/>
+            <a:ext cx="4278843" cy="1334999"/>
           </a:xfrm>
           <a:prstGeom prst="rect">
             <a:avLst/>
@@ -2468,13 +2574,13 @@
       </p:pic>
       <p:sp>
         <p:nvSpPr>
-          <p:cNvPr id="40" name="Text 35"/>
-          <p:cNvSpPr txBox="1"/>
-          <p:nvPr/>
-        </p:nvSpPr>
-        <p:spPr>
-          <a:xfrm>
-            <a:off x="539496" y="6721511"/>
+          <p:cNvPr id="43" name="Text 38"/>
+          <p:cNvSpPr txBox="1"/>
+          <p:nvPr/>
+        </p:nvSpPr>
+        <p:spPr>
+          <a:xfrm>
+            <a:off x="539496" y="7138645"/>
             <a:ext cx="6483096" cy="488975"/>
           </a:xfrm>
           <a:prstGeom prst="rect">
@@ -2510,13 +2616,13 @@
       </p:sp>
       <p:sp>
         <p:nvSpPr>
-          <p:cNvPr id="41" name="Text 36"/>
-          <p:cNvSpPr txBox="1"/>
-          <p:nvPr/>
-        </p:nvSpPr>
-        <p:spPr>
-          <a:xfrm>
-            <a:off x="539496" y="7326615"/>
+          <p:cNvPr id="44" name="Text 39"/>
+          <p:cNvSpPr txBox="1"/>
+          <p:nvPr/>
+        </p:nvSpPr>
+        <p:spPr>
+          <a:xfrm>
+            <a:off x="539496" y="7743749"/>
             <a:ext cx="6483096" cy="219456"/>
           </a:xfrm>
           <a:prstGeom prst="rect">
@@ -2549,13 +2655,13 @@
       </p:sp>
       <p:sp>
         <p:nvSpPr>
-          <p:cNvPr id="42" name="Text 37"/>
-          <p:cNvSpPr txBox="1"/>
-          <p:nvPr/>
-        </p:nvSpPr>
-        <p:spPr>
-          <a:xfrm>
-            <a:off x="539496" y="7573503"/>
+          <p:cNvPr id="45" name="Text 40"/>
+          <p:cNvSpPr txBox="1"/>
+          <p:nvPr/>
+        </p:nvSpPr>
+        <p:spPr>
+          <a:xfrm>
+            <a:off x="539496" y="7990637"/>
             <a:ext cx="6483096" cy="802767"/>
           </a:xfrm>
           <a:prstGeom prst="rect">
@@ -2591,13 +2697,13 @@
       </p:sp>
       <p:sp>
         <p:nvSpPr>
-          <p:cNvPr id="43" name="Shape 38"/>
+          <p:cNvPr id="46" name="Shape 41"/>
           <p:cNvSpPr/>
           <p:nvPr/>
         </p:nvSpPr>
         <p:spPr>
           <a:xfrm>
-            <a:off x="3781044" y="8492399"/>
+            <a:off x="3781044" y="8909533"/>
             <a:ext cx="0" cy="985647"/>
           </a:xfrm>
           <a:prstGeom prst="line">
@@ -2614,13 +2720,13 @@
       </p:sp>
       <p:sp>
         <p:nvSpPr>
-          <p:cNvPr id="44" name="Text 39"/>
-          <p:cNvSpPr txBox="1"/>
-          <p:nvPr/>
-        </p:nvSpPr>
-        <p:spPr>
-          <a:xfrm>
-            <a:off x="539496" y="8492399"/>
+          <p:cNvPr id="47" name="Text 42"/>
+          <p:cNvSpPr txBox="1"/>
+          <p:nvPr/>
+        </p:nvSpPr>
+        <p:spPr>
+          <a:xfrm>
+            <a:off x="539496" y="8909533"/>
             <a:ext cx="3058668" cy="155448"/>
           </a:xfrm>
           <a:prstGeom prst="rect">
@@ -2653,13 +2759,13 @@
       </p:sp>
       <p:sp>
         <p:nvSpPr>
-          <p:cNvPr id="45" name="Text 40"/>
-          <p:cNvSpPr txBox="1"/>
-          <p:nvPr/>
-        </p:nvSpPr>
-        <p:spPr>
-          <a:xfrm>
-            <a:off x="539496" y="8684423"/>
+          <p:cNvPr id="48" name="Text 43"/>
+          <p:cNvSpPr txBox="1"/>
+          <p:nvPr/>
+        </p:nvSpPr>
+        <p:spPr>
+          <a:xfrm>
+            <a:off x="539496" y="9101557"/>
             <a:ext cx="3058668" cy="784479"/>
           </a:xfrm>
           <a:prstGeom prst="rect">
@@ -2695,13 +2801,13 @@
       </p:sp>
       <p:sp>
         <p:nvSpPr>
-          <p:cNvPr id="46" name="Text 41"/>
-          <p:cNvSpPr txBox="1"/>
-          <p:nvPr/>
-        </p:nvSpPr>
-        <p:spPr>
-          <a:xfrm>
-            <a:off x="3963924" y="8492399"/>
+          <p:cNvPr id="49" name="Text 44"/>
+          <p:cNvSpPr txBox="1"/>
+          <p:nvPr/>
+        </p:nvSpPr>
+        <p:spPr>
+          <a:xfrm>
+            <a:off x="3963924" y="8909533"/>
             <a:ext cx="3058668" cy="155448"/>
           </a:xfrm>
           <a:prstGeom prst="rect">
@@ -2734,13 +2840,13 @@
       </p:sp>
       <p:sp>
         <p:nvSpPr>
-          <p:cNvPr id="47" name="Text 42"/>
-          <p:cNvSpPr txBox="1"/>
-          <p:nvPr/>
-        </p:nvSpPr>
-        <p:spPr>
-          <a:xfrm>
-            <a:off x="3963924" y="8684423"/>
+          <p:cNvPr id="50" name="Text 45"/>
+          <p:cNvSpPr txBox="1"/>
+          <p:nvPr/>
+        </p:nvSpPr>
+        <p:spPr>
+          <a:xfrm>
+            <a:off x="3963924" y="9101557"/>
             <a:ext cx="3058668" cy="784479"/>
           </a:xfrm>
           <a:prstGeom prst="rect">

</xml_diff>

<commit_message>
Epiroc Q3 2026: reaction read as -2.0% after a -5.1% intraday low
Co-Authored-By: Claude Opus 5.5 <noreply@anthropic.com>
Claude-Session: https://claude.ai/code/session_014JFw9wsnkgedq53FQx57gS
</commit_message>
<xml_diff>
--- a/reports/EPIA_Q3_2026/Earnings_Update_EPIA_Q32026.pptx
+++ b/reports/EPIA_Q3_2026/Earnings_Update_EPIA_Q32026.pptx
@@ -1594,7 +1594,7 @@
             <a:r>
               <a:rPr lang="en-US" sz="700" b="1" spc="80" kern="0" dirty="0">
                 <a:solidFill>
-                  <a:srgbClr val="FF6C0E"/>
+                  <a:srgbClr val="4B5F80"/>
                 </a:solidFill>
                 <a:latin typeface="Nunito" pitchFamily="34" charset="0"/>
                 <a:ea typeface="Nunito" pitchFamily="34" charset="-122"/>
@@ -1642,7 +1642,7 @@
                 <a:ea typeface="Nunito" pitchFamily="34" charset="-122"/>
                 <a:cs typeface="Nunito" pitchFamily="34" charset="-120"/>
               </a:rPr>
-              <a:t>Shares down 5.1% on 28 October: equipment orders grew 16% organically, against about 26% expected.</a:t>
+              <a:t>Shares down 2.0% on 28 October after 5.1% intraday; we think margins and copper cushioned the miss.</a:t>
             </a:r>
             <a:endParaRPr lang="en-US" sz="870" dirty="0"/>
           </a:p>
@@ -2447,7 +2447,7 @@
                 <a:ea typeface="Nunito" pitchFamily="34" charset="-122"/>
                 <a:cs typeface="Nunito" pitchFamily="34" charset="-120"/>
               </a:rPr>
-              <a:t>Revenue missed consensus by 3.0% and earnings per share by 6.5%, and the shares fell 5.1% by early afternoon on 28 October: miss and reaction are aligned. The margin was the bright spot at 20.4%, up from 19.0%, but equipment orders grew 16% organically against 30% in the second quarter, and cash conversion weakened sharply.</a:t>
+              <a:t>Revenue missed consensus by 3.0% and earnings per share by 6.5%, yet the shares were down only 2.0% later on 28 October, after falling 5.1% intraday: a muted reaction to a clear miss. The margin was the bright spot at 20.4%, up from 19.0%, but equipment orders grew 16% organically against 30% in the second quarter, and cash conversion weakened sharply.</a:t>
             </a:r>
             <a:endParaRPr lang="en-US" sz="870" dirty="0"/>
           </a:p>
@@ -3167,7 +3167,7 @@
         <p:spPr>
           <a:xfrm>
             <a:off x="539496" y="2525116"/>
-            <a:ext cx="6483096" cy="802767"/>
+            <a:ext cx="6483096" cy="959663"/>
           </a:xfrm>
           <a:prstGeom prst="rect">
             <a:avLst/>
@@ -3194,7 +3194,7 @@
                 <a:ea typeface="Nunito" pitchFamily="34" charset="-122"/>
                 <a:cs typeface="Nunito" pitchFamily="34" charset="-120"/>
               </a:rPr>
-              <a:t>A miss on revenue, operating profit and earnings met a 5.1% fall by 13:27 GMT on 28 October: surprise and reaction are aligned. The confirmed drivers go beyond the headline: equipment orders grew 16% organically against analyst expectations of about 26%, surface tenders did not convert, the infrastructure outlook was trimmed from “increase somewhat” to “remain stable”, and operating cash flow fell to SEK 1.4bn from 2.5bn. Expectations were already easing, in our reading: the shares had fallen 6.5% in the two weeks before the release, which may have limited the move.</a:t>
+              <a:t>A miss on revenue, operating profit and earnings met only a 2.0% fall on 28 October, after a 5.1% intraday drop: the reaction is small relative to the surprise. The weak points are confirmed: equipment orders grew 16% organically against analyst expectations of about 26%, surface tenders did not convert, the infrastructure outlook was trimmed to “remain stable” and operating cash flow fell to SEK 1.4bn from 2.5bn. The most likely reading is that investors looked through them to the 20.4% margin and a copper pipeline management calls very strong; a 6.5% fall in the two weeks before the release had also lowered expectations.</a:t>
             </a:r>
             <a:endParaRPr lang="en-US" sz="870" dirty="0"/>
           </a:p>
@@ -3208,7 +3208,7 @@
         </p:nvSpPr>
         <p:spPr>
           <a:xfrm>
-            <a:off x="539496" y="3444011"/>
+            <a:off x="539496" y="3600907"/>
             <a:ext cx="6483096" cy="219456"/>
           </a:xfrm>
           <a:prstGeom prst="rect">
@@ -3247,7 +3247,7 @@
         </p:nvSpPr>
         <p:spPr>
           <a:xfrm>
-            <a:off x="539496" y="3690899"/>
+            <a:off x="539496" y="3847795"/>
             <a:ext cx="6483096" cy="959663"/>
           </a:xfrm>
           <a:prstGeom prst="rect">
@@ -3289,7 +3289,7 @@
         </p:nvSpPr>
         <p:spPr>
           <a:xfrm>
-            <a:off x="539496" y="4766691"/>
+            <a:off x="539496" y="4923587"/>
             <a:ext cx="6483096" cy="219456"/>
           </a:xfrm>
           <a:prstGeom prst="rect">
@@ -3328,7 +3328,7 @@
         </p:nvSpPr>
         <p:spPr>
           <a:xfrm>
-            <a:off x="539496" y="5013579"/>
+            <a:off x="539496" y="5170475"/>
             <a:ext cx="6483096" cy="173736"/>
           </a:xfrm>
           <a:prstGeom prst="rect">
@@ -3381,7 +3381,7 @@
         </p:nvSpPr>
         <p:spPr>
           <a:xfrm>
-            <a:off x="539496" y="5187315"/>
+            <a:off x="539496" y="5344211"/>
             <a:ext cx="6483096" cy="115570"/>
           </a:xfrm>
           <a:prstGeom prst="rect">
@@ -3431,7 +3431,7 @@
         </p:blipFill>
         <p:spPr>
           <a:xfrm>
-            <a:off x="928482" y="5348605"/>
+            <a:off x="928482" y="5505501"/>
             <a:ext cx="5705124" cy="3413946"/>
           </a:xfrm>
           <a:prstGeom prst="rect">
@@ -3447,7 +3447,7 @@
         </p:nvSpPr>
         <p:spPr>
           <a:xfrm>
-            <a:off x="539496" y="8817415"/>
+            <a:off x="539496" y="8974311"/>
             <a:ext cx="6483096" cy="802767"/>
           </a:xfrm>
           <a:prstGeom prst="rect">

</xml_diff>